<commit_message>
docs: add IAM deep-dive slide containing PEP/PDP/PIP logic and advanced security concepts to presentation
</commit_message>
<xml_diff>
--- a/docs/SecurePrompt_AI_Gateway_Presentation.pptx
+++ b/docs/SecurePrompt_AI_Gateway_Presentation.pptx
@@ -14,6 +14,7 @@
     <p:sldId id="262" r:id="rId13"/>
     <p:sldId id="263" r:id="rId14"/>
     <p:sldId id="264" r:id="rId15"/>
+    <p:sldId id="265" r:id="rId16"/>
   </p:sldIdLst>
   <p:sldSz cx="12191695" cy="6858000" type="screen4x3"/>
   <p:notesSz cx="6858000" cy="9144000"/>
@@ -3267,6 +3268,223 @@
 </p:sld>
 </file>
 
+<file path=ppt/slides/slide10.xml><?xml version="1.0" encoding="utf-8"?>
+<p:sld xmlns:a="http://schemas.openxmlformats.org/drawingml/2006/main" xmlns:p="http://schemas.openxmlformats.org/presentationml/2006/main" xmlns:r="http://schemas.openxmlformats.org/officeDocument/2006/relationships">
+  <p:cSld>
+    <p:bg>
+      <p:bgPr>
+        <a:solidFill>
+          <a:srgbClr val="0B0F19"/>
+        </a:solidFill>
+        <a:effectLst/>
+      </p:bgPr>
+    </p:bg>
+    <p:spTree>
+      <p:nvGrpSpPr>
+        <p:cNvPr id="1" name=""/>
+        <p:cNvGrpSpPr/>
+        <p:nvPr/>
+      </p:nvGrpSpPr>
+      <p:grpSpPr/>
+      <p:sp>
+        <p:nvSpPr>
+          <p:cNvPr id="2" name="TextBox 1"/>
+          <p:cNvSpPr txBox="1"/>
+          <p:nvPr/>
+        </p:nvSpPr>
+        <p:spPr>
+          <a:xfrm>
+            <a:off x="731520" y="365760"/>
+            <a:ext cx="10698480" cy="274320"/>
+          </a:xfrm>
+          <a:prstGeom prst="rect">
+            <a:avLst/>
+          </a:prstGeom>
+          <a:noFill/>
+        </p:spPr>
+        <p:txBody>
+          <a:bodyPr wrap="square" lIns="0" rIns="0" tIns="0" bIns="0">
+            <a:spAutoFit/>
+          </a:bodyPr>
+          <a:lstStyle/>
+          <a:p>
+            <a:pPr algn="l">
+              <a:defRPr sz="1000" b="1">
+                <a:solidFill>
+                  <a:srgbClr val="818CF8"/>
+                </a:solidFill>
+                <a:latin typeface="Calibri"/>
+              </a:defRPr>
+            </a:pPr>
+            <a:r>
+              <a:t>SECUREPROMPT AI GATEWAY</a:t>
+            </a:r>
+          </a:p>
+        </p:txBody>
+      </p:sp>
+      <p:sp>
+        <p:nvSpPr>
+          <p:cNvPr id="3" name="TextBox 2"/>
+          <p:cNvSpPr txBox="1"/>
+          <p:nvPr/>
+        </p:nvSpPr>
+        <p:spPr>
+          <a:xfrm>
+            <a:off x="731520" y="640080"/>
+            <a:ext cx="10698480" cy="731520"/>
+          </a:xfrm>
+          <a:prstGeom prst="rect">
+            <a:avLst/>
+          </a:prstGeom>
+          <a:noFill/>
+        </p:spPr>
+        <p:txBody>
+          <a:bodyPr wrap="square" lIns="0" rIns="0" tIns="0" bIns="0">
+            <a:spAutoFit/>
+          </a:bodyPr>
+          <a:lstStyle/>
+          <a:p>
+            <a:pPr algn="l">
+              <a:defRPr sz="2800" b="1">
+                <a:solidFill>
+                  <a:srgbClr val="FFFFFF"/>
+                </a:solidFill>
+                <a:latin typeface="Calibri"/>
+              </a:defRPr>
+            </a:pPr>
+            <a:r>
+              <a:t>Summary &amp; Career Roadmap: Security with AI</a:t>
+            </a:r>
+          </a:p>
+        </p:txBody>
+      </p:sp>
+      <p:sp>
+        <p:nvSpPr>
+          <p:cNvPr id="4" name="TextBox 3"/>
+          <p:cNvSpPr txBox="1"/>
+          <p:nvPr/>
+        </p:nvSpPr>
+        <p:spPr>
+          <a:xfrm>
+            <a:off x="731520" y="1645920"/>
+            <a:ext cx="10698480" cy="4572000"/>
+          </a:xfrm>
+          <a:prstGeom prst="rect">
+            <a:avLst/>
+          </a:prstGeom>
+          <a:noFill/>
+        </p:spPr>
+        <p:txBody>
+          <a:bodyPr wrap="square" lIns="0" rIns="0" tIns="0" bIns="0">
+            <a:spAutoFit/>
+          </a:bodyPr>
+          <a:lstStyle/>
+          <a:p>
+            <a:pPr>
+              <a:spcAft>
+                <a:spcPts val="1000"/>
+              </a:spcAft>
+              <a:defRPr sz="1500">
+                <a:solidFill>
+                  <a:srgbClr val="94A3B8"/>
+                </a:solidFill>
+                <a:latin typeface="Calibri"/>
+              </a:defRPr>
+            </a:pPr>
+            <a:r>
+              <a:t>•  Full-Stack Foundation: Built a high-performance, containerized, and deployed firewall bridging Web App engineering and AI governance.</a:t>
+            </a:r>
+          </a:p>
+          <a:p>
+            <a:pPr>
+              <a:spcAft>
+                <a:spcPts val="1000"/>
+              </a:spcAft>
+              <a:defRPr sz="1500">
+                <a:solidFill>
+                  <a:srgbClr val="94A3B8"/>
+                </a:solidFill>
+                <a:latin typeface="Calibri"/>
+              </a:defRPr>
+            </a:pPr>
+            <a:r>
+              <a:t>•  Core Skill Demonstration: Showcases strong proficiency in IAM (RBAC, Scrypt Hashing, Token Contexts) and DLP (Regex, Heuristics, Policy Engine).</a:t>
+            </a:r>
+          </a:p>
+          <a:p>
+            <a:pPr>
+              <a:spcAft>
+                <a:spcPts val="1000"/>
+              </a:spcAft>
+              <a:defRPr sz="1500">
+                <a:solidFill>
+                  <a:srgbClr val="94A3B8"/>
+                </a:solidFill>
+                <a:latin typeface="Calibri"/>
+              </a:defRPr>
+            </a:pPr>
+            <a:r>
+              <a:t>•  Future AI Security Use Cases to Propose to Manager:</a:t>
+            </a:r>
+          </a:p>
+          <a:p>
+            <a:pPr>
+              <a:spcAft>
+                <a:spcPts val="1000"/>
+              </a:spcAft>
+              <a:defRPr sz="1500">
+                <a:solidFill>
+                  <a:srgbClr val="94A3B8"/>
+                </a:solidFill>
+                <a:latin typeface="Calibri"/>
+              </a:defRPr>
+            </a:pPr>
+            <a:r>
+              <a:t>•     1. LLM Evaluation &amp; Guardrails: Add alignment scanners (hallucination checks, toxic output filtering, prompt alignment).</a:t>
+            </a:r>
+          </a:p>
+          <a:p>
+            <a:pPr>
+              <a:spcAft>
+                <a:spcPts val="1000"/>
+              </a:spcAft>
+              <a:defRPr sz="1500">
+                <a:solidFill>
+                  <a:srgbClr val="94A3B8"/>
+                </a:solidFill>
+                <a:latin typeface="Calibri"/>
+              </a:defRPr>
+            </a:pPr>
+            <a:r>
+              <a:t>•     2. Vector DB Sanitization: Implement safe embeddings (strip PII before converting prompts to vectors for retrieval-augmented generation).</a:t>
+            </a:r>
+          </a:p>
+          <a:p>
+            <a:pPr>
+              <a:spcAft>
+                <a:spcPts val="1000"/>
+              </a:spcAft>
+              <a:defRPr sz="1500">
+                <a:solidFill>
+                  <a:srgbClr val="94A3B8"/>
+                </a:solidFill>
+                <a:latin typeface="Calibri"/>
+              </a:defRPr>
+            </a:pPr>
+            <a:r>
+              <a:t>•     3. API Key Vault Integration: Store target LLM API keys in HashiCorp Vault or AWS Secrets Manager, injected dynamically by the gateway.</a:t>
+            </a:r>
+          </a:p>
+        </p:txBody>
+      </p:sp>
+    </p:spTree>
+  </p:cSld>
+  <p:clrMapOvr>
+    <a:masterClrMapping/>
+  </p:clrMapOvr>
+</p:sld>
+</file>
+
 <file path=ppt/slides/slide2.xml><?xml version="1.0" encoding="utf-8"?>
 <p:sld xmlns:a="http://schemas.openxmlformats.org/drawingml/2006/main" xmlns:p="http://schemas.openxmlformats.org/presentationml/2006/main" xmlns:r="http://schemas.openxmlformats.org/officeDocument/2006/relationships">
   <p:cSld>
@@ -5322,7 +5540,7 @@
               </a:defRPr>
             </a:pPr>
             <a:r>
-              <a:t>Summary &amp; Career Roadmap: Security with AI</a:t>
+              <a:t>IAM Deep-Dive: Role-Based Data Management</a:t>
             </a:r>
           </a:p>
         </p:txBody>
@@ -5336,7 +5554,7 @@
         <p:spPr>
           <a:xfrm>
             <a:off x="731520" y="1645920"/>
-            <a:ext cx="10698480" cy="4572000"/>
+            <a:ext cx="5029200" cy="365760"/>
           </a:xfrm>
           <a:prstGeom prst="rect">
             <a:avLst/>
@@ -5349,11 +5567,47 @@
           </a:bodyPr>
           <a:lstStyle/>
           <a:p>
+            <a:pPr algn="l">
+              <a:defRPr sz="1400" b="1">
+                <a:solidFill>
+                  <a:srgbClr val="818CF8"/>
+                </a:solidFill>
+                <a:latin typeface="Calibri"/>
+              </a:defRPr>
+            </a:pPr>
+            <a:r>
+              <a:t>PEP / PDP / PIP Implementation Flow</a:t>
+            </a:r>
+          </a:p>
+        </p:txBody>
+      </p:sp>
+      <p:sp>
+        <p:nvSpPr>
+          <p:cNvPr id="5" name="TextBox 4"/>
+          <p:cNvSpPr txBox="1"/>
+          <p:nvPr/>
+        </p:nvSpPr>
+        <p:spPr>
+          <a:xfrm>
+            <a:off x="731520" y="2103120"/>
+            <a:ext cx="5029200" cy="4114800"/>
+          </a:xfrm>
+          <a:prstGeom prst="rect">
+            <a:avLst/>
+          </a:prstGeom>
+          <a:noFill/>
+        </p:spPr>
+        <p:txBody>
+          <a:bodyPr wrap="square" lIns="0" rIns="0" tIns="0" bIns="0">
+            <a:spAutoFit/>
+          </a:bodyPr>
+          <a:lstStyle/>
+          <a:p>
             <a:pPr>
               <a:spcAft>
                 <a:spcPts val="1000"/>
               </a:spcAft>
-              <a:defRPr sz="1500">
+              <a:defRPr sz="1300">
                 <a:solidFill>
                   <a:srgbClr val="94A3B8"/>
                 </a:solidFill>
@@ -5361,7 +5615,7 @@
               </a:defRPr>
             </a:pPr>
             <a:r>
-              <a:t>•  Full-Stack Foundation: Built a high-performance, containerized, and deployed firewall bridging Web App engineering and AI governance.</a:t>
+              <a:t>•  PEP (Policy Enforcement Point): FastAPI gateway intercepts the incoming request and validates the X-User-Id header context.</a:t>
             </a:r>
           </a:p>
           <a:p>
@@ -5369,7 +5623,7 @@
               <a:spcAft>
                 <a:spcPts val="1000"/>
               </a:spcAft>
-              <a:defRPr sz="1500">
+              <a:defRPr sz="1300">
                 <a:solidFill>
                   <a:srgbClr val="94A3B8"/>
                 </a:solidFill>
@@ -5377,7 +5631,7 @@
               </a:defRPr>
             </a:pPr>
             <a:r>
-              <a:t>•  Core Skill Demonstration: Showcases strong proficiency in IAM (RBAC, Scrypt Hashing, Token Contexts) and DLP (Regex, Heuristics, Policy Engine).</a:t>
+              <a:t>•  PDP (Policy Decision Point): The backend resolves authorization by querying the database to fetch the active user role ('developer' vs 'security_admin').</a:t>
             </a:r>
           </a:p>
           <a:p>
@@ -5385,7 +5639,7 @@
               <a:spcAft>
                 <a:spcPts val="1000"/>
               </a:spcAft>
-              <a:defRPr sz="1500">
+              <a:defRPr sz="1300">
                 <a:solidFill>
                   <a:srgbClr val="94A3B8"/>
                 </a:solidFill>
@@ -5393,7 +5647,7 @@
               </a:defRPr>
             </a:pPr>
             <a:r>
-              <a:t>•  Future AI Security Use Cases to Propose to Manager:</a:t>
+              <a:t>•  PIP (Policy Information Point): Dynamic query filtering acts as Row-Level Security. Developers only query and view logs where AuditLog.user matches their email.</a:t>
             </a:r>
           </a:p>
           <a:p>
@@ -5401,7 +5655,7 @@
               <a:spcAft>
                 <a:spcPts val="1000"/>
               </a:spcAft>
-              <a:defRPr sz="1500">
+              <a:defRPr sz="1300">
                 <a:solidFill>
                   <a:srgbClr val="94A3B8"/>
                 </a:solidFill>
@@ -5409,15 +5663,74 @@
               </a:defRPr>
             </a:pPr>
             <a:r>
-              <a:t>•     1. LLM Evaluation &amp; Guardrails: Add alignment scanners (hallucination checks, toxic output filtering, prompt alignment).</a:t>
-            </a:r>
-          </a:p>
+              <a:t>•  Observability Separation: Security Admins bypass row filters to perform aggregated analytics across the entire tenant's data logs.</a:t>
+            </a:r>
+          </a:p>
+        </p:txBody>
+      </p:sp>
+      <p:sp>
+        <p:nvSpPr>
+          <p:cNvPr id="6" name="TextBox 5"/>
+          <p:cNvSpPr txBox="1"/>
+          <p:nvPr/>
+        </p:nvSpPr>
+        <p:spPr>
+          <a:xfrm>
+            <a:off x="6400800" y="1645920"/>
+            <a:ext cx="5029200" cy="365760"/>
+          </a:xfrm>
+          <a:prstGeom prst="rect">
+            <a:avLst/>
+          </a:prstGeom>
+          <a:noFill/>
+        </p:spPr>
+        <p:txBody>
+          <a:bodyPr wrap="square" lIns="0" rIns="0" tIns="0" bIns="0">
+            <a:spAutoFit/>
+          </a:bodyPr>
+          <a:lstStyle/>
+          <a:p>
+            <a:pPr algn="l">
+              <a:defRPr sz="1400" b="1">
+                <a:solidFill>
+                  <a:srgbClr val="34D399"/>
+                </a:solidFill>
+                <a:latin typeface="Calibri"/>
+              </a:defRPr>
+            </a:pPr>
+            <a:r>
+              <a:t>Future Enterprise IAM &amp; Security Concepts</a:t>
+            </a:r>
+          </a:p>
+        </p:txBody>
+      </p:sp>
+      <p:sp>
+        <p:nvSpPr>
+          <p:cNvPr id="7" name="TextBox 6"/>
+          <p:cNvSpPr txBox="1"/>
+          <p:nvPr/>
+        </p:nvSpPr>
+        <p:spPr>
+          <a:xfrm>
+            <a:off x="6400800" y="2103120"/>
+            <a:ext cx="5029200" cy="4114800"/>
+          </a:xfrm>
+          <a:prstGeom prst="rect">
+            <a:avLst/>
+          </a:prstGeom>
+          <a:noFill/>
+        </p:spPr>
+        <p:txBody>
+          <a:bodyPr wrap="square" lIns="0" rIns="0" tIns="0" bIns="0">
+            <a:spAutoFit/>
+          </a:bodyPr>
+          <a:lstStyle/>
           <a:p>
             <a:pPr>
               <a:spcAft>
                 <a:spcPts val="1000"/>
               </a:spcAft>
-              <a:defRPr sz="1500">
+              <a:defRPr sz="1300">
                 <a:solidFill>
                   <a:srgbClr val="94A3B8"/>
                 </a:solidFill>
@@ -5425,7 +5738,7 @@
               </a:defRPr>
             </a:pPr>
             <a:r>
-              <a:t>•     2. Vector DB Sanitization: Implement safe embeddings (strip PII before converting prompts to vectors for retrieval-augmented generation).</a:t>
+              <a:t>•  Signed JWT Claims: Transition to JSON Web Tokens (JWT) to cryptographically sign claims (email, role, department), avoiding database roundtrips.</a:t>
             </a:r>
           </a:p>
           <a:p>
@@ -5433,7 +5746,7 @@
               <a:spcAft>
                 <a:spcPts val="1000"/>
               </a:spcAft>
-              <a:defRPr sz="1500">
+              <a:defRPr sz="1300">
                 <a:solidFill>
                   <a:srgbClr val="94A3B8"/>
                 </a:solidFill>
@@ -5441,7 +5754,39 @@
               </a:defRPr>
             </a:pPr>
             <a:r>
-              <a:t>•     3. API Key Vault Integration: Store target LLM API keys in HashiCorp Vault or AWS Secrets Manager, injected dynamically by the gateway.</a:t>
+              <a:t>•  PII Tokenization Vault: Use a secure token vault to replace sensitive PII (e.g. name) with temporary tokens (e.g. TOKEN_98) before LLM routing, detokenizing on return.</a:t>
+            </a:r>
+          </a:p>
+          <a:p>
+            <a:pPr>
+              <a:spcAft>
+                <a:spcPts val="1000"/>
+              </a:spcAft>
+              <a:defRPr sz="1300">
+                <a:solidFill>
+                  <a:srgbClr val="94A3B8"/>
+                </a:solidFill>
+                <a:latin typeface="Calibri"/>
+              </a:defRPr>
+            </a:pPr>
+            <a:r>
+              <a:t>•  LLM Credential Vaulting: Store model API keys in HashiCorp Vault or AWS Secrets Manager. Gateway proxies requests to enforce Least Privilege access.</a:t>
+            </a:r>
+          </a:p>
+          <a:p>
+            <a:pPr>
+              <a:spcAft>
+                <a:spcPts val="1000"/>
+              </a:spcAft>
+              <a:defRPr sz="1300">
+                <a:solidFill>
+                  <a:srgbClr val="94A3B8"/>
+                </a:solidFill>
+                <a:latin typeface="Calibri"/>
+              </a:defRPr>
+            </a:pPr>
+            <a:r>
+              <a:t>•  Attribute-Based Access Control (ABAC): Control LLM routing and rate-limiting using attributes like department budgets, time-of-day, and prompt costs.</a:t>
             </a:r>
           </a:p>
         </p:txBody>

</xml_diff>